<commit_message>
Add context and harness course demos
</commit_message>
<xml_diff>
--- a/context-engineering-course/docs/上下文工程.pptx
+++ b/context-engineering-course/docs/上下文工程.pptx
@@ -4654,36 +4654,36 @@
 </file>
 
 <file path=ppt/slides/slide15.xml><?xml version="1.0" encoding="utf-8"?>
-<p:sld xmlns:a="http://schemas.openxmlformats.org/drawingml/2006/main" xmlns:r="http://schemas.openxmlformats.org/officeDocument/2006/relationships" xmlns:p="http://schemas.openxmlformats.org/presentationml/2006/main">
-  <p:cSld name="Slide 15">
-    <p:bg>
-      <p:bgPr>
+<ns0:sld xmlns:a="http://schemas.openxmlformats.org/drawingml/2006/main" xmlns:ns0="http://schemas.openxmlformats.org/presentationml/2006/main">
+  <ns0:cSld name="Slide 15">
+    <ns0:bg>
+      <ns0:bgPr>
         <a:solidFill>
           <a:srgbClr val="2C5F2D"/>
         </a:solidFill>
-      </p:bgPr>
-    </p:bg>
-    <p:spTree>
-      <p:nvGrpSpPr>
-        <p:cNvPr id="1" name=""/>
-        <p:cNvGrpSpPr/>
-        <p:nvPr/>
-      </p:nvGrpSpPr>
-      <p:grpSpPr>
+      </ns0:bgPr>
+    </ns0:bg>
+    <ns0:spTree>
+      <ns0:nvGrpSpPr>
+        <ns0:cNvPr id="1" name=""/>
+        <ns0:cNvGrpSpPr/>
+        <ns0:nvPr/>
+      </ns0:nvGrpSpPr>
+      <ns0:grpSpPr>
         <a:xfrm>
           <a:off x="0" y="0"/>
           <a:ext cx="0" cy="0"/>
           <a:chOff x="0" y="0"/>
           <a:chExt cx="0" cy="0"/>
         </a:xfrm>
-      </p:grpSpPr>
-      <p:sp>
-        <p:nvSpPr>
-          <p:cNvPr id="2" name="Text 0"/>
-          <p:cNvSpPr/>
-          <p:nvPr/>
-        </p:nvSpPr>
-        <p:spPr>
+      </ns0:grpSpPr>
+      <ns0:sp>
+        <ns0:nvSpPr>
+          <ns0:cNvPr id="2" name="Text 0"/>
+          <ns0:cNvSpPr/>
+          <ns0:nvPr/>
+        </ns0:nvSpPr>
+        <ns0:spPr>
           <a:xfrm>
             <a:off x="457200" y="731520"/>
             <a:ext cx="8229600" cy="731520"/>
@@ -4693,8 +4693,8 @@
           </a:prstGeom>
           <a:noFill/>
           <a:ln/>
-        </p:spPr>
-        <p:txBody>
+        </ns0:spPr>
+        <ns0:txBody>
           <a:bodyPr wrap="square" rtlCol="0" anchor="ctr"/>
           <a:lstStyle/>
           <a:p>
@@ -4714,15 +4714,15 @@
             </a:r>
             <a:endParaRPr lang="en-US" sz="3600" dirty="0"/>
           </a:p>
-        </p:txBody>
-      </p:sp>
-      <p:sp>
-        <p:nvSpPr>
-          <p:cNvPr id="3" name="Shape 1"/>
-          <p:cNvSpPr/>
-          <p:nvPr/>
-        </p:nvSpPr>
-        <p:spPr>
+        </ns0:txBody>
+      </ns0:sp>
+      <ns0:sp>
+        <ns0:nvSpPr>
+          <ns0:cNvPr id="3" name="Shape 1"/>
+          <ns0:cNvSpPr/>
+          <ns0:nvPr/>
+        </ns0:nvSpPr>
+        <ns0:spPr>
           <a:xfrm>
             <a:off x="3200400" y="1463040"/>
             <a:ext cx="2743200" cy="45720"/>
@@ -4734,15 +4734,15 @@
             <a:srgbClr val="97BC62"/>
           </a:solidFill>
           <a:ln/>
-        </p:spPr>
-      </p:sp>
-      <p:sp>
-        <p:nvSpPr>
-          <p:cNvPr id="4" name="Text 2"/>
-          <p:cNvSpPr/>
-          <p:nvPr/>
-        </p:nvSpPr>
-        <p:spPr>
+        </ns0:spPr>
+      </ns0:sp>
+      <ns0:sp>
+        <ns0:nvSpPr>
+          <ns0:cNvPr id="4" name="Text 2"/>
+          <ns0:cNvSpPr/>
+          <ns0:nvPr/>
+        </ns0:nvSpPr>
+        <ns0:spPr>
           <a:xfrm>
             <a:off x="457200" y="1828800"/>
             <a:ext cx="8229600" cy="2286000"/>
@@ -4752,8 +4752,8 @@
           </a:prstGeom>
           <a:noFill/>
           <a:ln/>
-        </p:spPr>
-        <p:txBody>
+        </ns0:spPr>
+        <ns0:txBody>
           <a:bodyPr wrap="square" rtlCol="0" anchor="ctr"/>
           <a:lstStyle/>
           <a:p>
@@ -4769,7 +4769,7 @@
                 <a:ea typeface="Microsoft YaHei" pitchFamily="34" charset="-122"/>
                 <a:cs typeface="Microsoft YaHei" pitchFamily="34" charset="-120"/>
               </a:rPr>
-              <a:t>上下文工程是构建优秀AI应用的基础</a:t>
+              <a:t>上下文工程是构建可靠LLM应用的基础</a:t>
             </a:r>
             <a:endParaRPr lang="en-US" sz="2200" dirty="0"/>
           </a:p>
@@ -4803,7 +4803,7 @@
                 <a:ea typeface="Microsoft YaHei" pitchFamily="34" charset="-122"/>
                 <a:cs typeface="Microsoft YaHei" pitchFamily="34" charset="-120"/>
               </a:rPr>
-              <a:t>掌握记忆系统、RAG、上下文注入技术</a:t>
+              <a:t>掌握记忆系统、RAG、压缩与上下文注入技术</a:t>
             </a:r>
             <a:endParaRPr lang="en-US" sz="2200" dirty="0"/>
           </a:p>
@@ -4837,19 +4837,19 @@
                 <a:ea typeface="Microsoft YaHei" pitchFamily="34" charset="-122"/>
                 <a:cs typeface="Microsoft YaHei" pitchFamily="34" charset="-120"/>
               </a:rPr>
-              <a:t>持续优化上下文策略，提升用户体验</a:t>
+              <a:t>Notebook演示上下文分层、RAG评估、引用与冲突检查</a:t>
             </a:r>
             <a:endParaRPr lang="en-US" sz="2200" dirty="0"/>
           </a:p>
-        </p:txBody>
-      </p:sp>
-      <p:sp>
-        <p:nvSpPr>
-          <p:cNvPr id="5" name="Text 3"/>
-          <p:cNvSpPr/>
-          <p:nvPr/>
-        </p:nvSpPr>
-        <p:spPr>
+        </ns0:txBody>
+      </ns0:sp>
+      <ns0:sp>
+        <ns0:nvSpPr>
+          <ns0:cNvPr id="5" name="Text 3"/>
+          <ns0:cNvSpPr/>
+          <ns0:nvPr/>
+        </ns0:nvSpPr>
+        <ns0:spPr>
           <a:xfrm>
             <a:off x="457200" y="4114800"/>
             <a:ext cx="8229600" cy="731520"/>
@@ -4859,8 +4859,8 @@
           </a:prstGeom>
           <a:noFill/>
           <a:ln/>
-        </p:spPr>
-        <p:txBody>
+        </ns0:spPr>
+        <ns0:txBody>
           <a:bodyPr wrap="square" rtlCol="0" anchor="ctr"/>
           <a:lstStyle/>
           <a:p>
@@ -4876,51 +4876,51 @@
                 <a:ea typeface="Microsoft YaHei" pitchFamily="34" charset="-122"/>
                 <a:cs typeface="Microsoft YaHei" pitchFamily="34" charset="-120"/>
               </a:rPr>
-              <a:t>谢谢！</a:t>
+              <a:t>演示：examples/context_engineering_complete.ipynb</a:t>
             </a:r>
             <a:endParaRPr lang="en-US" sz="2800" dirty="0"/>
           </a:p>
-        </p:txBody>
-      </p:sp>
-    </p:spTree>
-  </p:cSld>
-  <p:clrMapOvr>
+        </ns0:txBody>
+      </ns0:sp>
+    </ns0:spTree>
+  </ns0:cSld>
+  <ns0:clrMapOvr>
     <a:masterClrMapping/>
-  </p:clrMapOvr>
-</p:sld>
+  </ns0:clrMapOvr>
+</ns0:sld>
 </file>
 
 <file path=ppt/slides/slide2.xml><?xml version="1.0" encoding="utf-8"?>
-<p:sld xmlns:a="http://schemas.openxmlformats.org/drawingml/2006/main" xmlns:r="http://schemas.openxmlformats.org/officeDocument/2006/relationships" xmlns:p="http://schemas.openxmlformats.org/presentationml/2006/main">
-  <p:cSld name="Slide 2">
-    <p:bg>
-      <p:bgPr>
+<ns0:sld xmlns:a="http://schemas.openxmlformats.org/drawingml/2006/main" xmlns:ns0="http://schemas.openxmlformats.org/presentationml/2006/main">
+  <ns0:cSld name="Slide 2">
+    <ns0:bg>
+      <ns0:bgPr>
         <a:solidFill>
           <a:srgbClr val="F5F5F5"/>
         </a:solidFill>
-      </p:bgPr>
-    </p:bg>
-    <p:spTree>
-      <p:nvGrpSpPr>
-        <p:cNvPr id="1" name=""/>
-        <p:cNvGrpSpPr/>
-        <p:nvPr/>
-      </p:nvGrpSpPr>
-      <p:grpSpPr>
+      </ns0:bgPr>
+    </ns0:bg>
+    <ns0:spTree>
+      <ns0:nvGrpSpPr>
+        <ns0:cNvPr id="1" name=""/>
+        <ns0:cNvGrpSpPr/>
+        <ns0:nvPr/>
+      </ns0:nvGrpSpPr>
+      <ns0:grpSpPr>
         <a:xfrm>
           <a:off x="0" y="0"/>
           <a:ext cx="0" cy="0"/>
           <a:chOff x="0" y="0"/>
           <a:chExt cx="0" cy="0"/>
         </a:xfrm>
-      </p:grpSpPr>
-      <p:sp>
-        <p:nvSpPr>
-          <p:cNvPr id="2" name="Shape 0"/>
-          <p:cNvSpPr/>
-          <p:nvPr/>
-        </p:nvSpPr>
-        <p:spPr>
+      </ns0:grpSpPr>
+      <ns0:sp>
+        <ns0:nvSpPr>
+          <ns0:cNvPr id="2" name="Shape 0"/>
+          <ns0:cNvSpPr/>
+          <ns0:nvPr/>
+        </ns0:nvSpPr>
+        <ns0:spPr>
           <a:xfrm>
             <a:off x="0" y="0"/>
             <a:ext cx="9144000" cy="914400"/>
@@ -4932,15 +4932,15 @@
             <a:srgbClr val="2C5F2D"/>
           </a:solidFill>
           <a:ln/>
-        </p:spPr>
-      </p:sp>
-      <p:sp>
-        <p:nvSpPr>
-          <p:cNvPr id="3" name="Text 1"/>
-          <p:cNvSpPr/>
-          <p:nvPr/>
-        </p:nvSpPr>
-        <p:spPr>
+        </ns0:spPr>
+      </ns0:sp>
+      <ns0:sp>
+        <ns0:nvSpPr>
+          <ns0:cNvPr id="3" name="Text 1"/>
+          <ns0:cNvSpPr/>
+          <ns0:nvPr/>
+        </ns0:nvSpPr>
+        <ns0:spPr>
           <a:xfrm>
             <a:off x="457200" y="182880"/>
             <a:ext cx="8229600" cy="548640"/>
@@ -4950,8 +4950,8 @@
           </a:prstGeom>
           <a:noFill/>
           <a:ln/>
-        </p:spPr>
-        <p:txBody>
+        </ns0:spPr>
+        <ns0:txBody>
           <a:bodyPr wrap="square" lIns="0" tIns="0" rIns="0" bIns="0" rtlCol="0" anchor="ctr"/>
           <a:lstStyle/>
           <a:p>
@@ -4971,15 +4971,15 @@
             </a:r>
             <a:endParaRPr lang="en-US" sz="2800" dirty="0"/>
           </a:p>
-        </p:txBody>
-      </p:sp>
-      <p:sp>
-        <p:nvSpPr>
-          <p:cNvPr id="4" name="Text 2"/>
-          <p:cNvSpPr/>
-          <p:nvPr/>
-        </p:nvSpPr>
-        <p:spPr>
+        </ns0:txBody>
+      </ns0:sp>
+      <ns0:sp>
+        <ns0:nvSpPr>
+          <ns0:cNvPr id="4" name="Text 2"/>
+          <ns0:cNvSpPr/>
+          <ns0:nvPr/>
+        </ns0:nvSpPr>
+        <ns0:spPr>
           <a:xfrm>
             <a:off x="914400" y="1371600"/>
             <a:ext cx="7315200" cy="3200400"/>
@@ -4989,8 +4989,8 @@
           </a:prstGeom>
           <a:noFill/>
           <a:ln/>
-        </p:spPr>
-        <p:txBody>
+        </ns0:spPr>
+        <ns0:txBody>
           <a:bodyPr wrap="square" rtlCol="0" anchor="ctr"/>
           <a:lstStyle/>
           <a:p>
@@ -5115,18 +5115,18 @@
                 <a:ea typeface="Microsoft YaHei" pitchFamily="34" charset="-122"/>
                 <a:cs typeface="Microsoft YaHei" pitchFamily="34" charset="-120"/>
               </a:rPr>
-              <a:t>最佳实践与案例</a:t>
+              <a:t>最佳实践、Notebook与案例</a:t>
             </a:r>
             <a:endParaRPr lang="en-US" sz="2200" dirty="0"/>
           </a:p>
-        </p:txBody>
-      </p:sp>
-    </p:spTree>
-  </p:cSld>
-  <p:clrMapOvr>
+        </ns0:txBody>
+      </ns0:sp>
+    </ns0:spTree>
+  </ns0:cSld>
+  <ns0:clrMapOvr>
     <a:masterClrMapping/>
-  </p:clrMapOvr>
-</p:sld>
+  </ns0:clrMapOvr>
+</ns0:sld>
 </file>
 
 <file path=ppt/slides/slide3.xml><?xml version="1.0" encoding="utf-8"?>

</xml_diff>